<commit_message>
docs: update presentation deck - add Adete Jain, remove job titles, and format Slide 2 to fit template
</commit_message>
<xml_diff>
--- a/CivicLens_AI_Pitch_Deck.pptx
+++ b/CivicLens_AI_Pitch_Deck.pptx
@@ -9,7 +9,6 @@
   </p:notesMasterIdLst>
   <p:sldIdLst>
     <p:sldId id="256" r:id="rId6"/>
-    <p:sldId id="257" r:id="rId7"/>
     <p:sldId id="258" r:id="rId8"/>
     <p:sldId id="259" r:id="rId9"/>
     <p:sldId id="260" r:id="rId10"/>
@@ -23,7 +22,6 @@
     <p:sldId id="268" r:id="rId18"/>
     <p:sldId id="269" r:id="rId19"/>
     <p:sldId id="270" r:id="rId20"/>
-    <p:sldId id="271" r:id="rId21"/>
   </p:sldIdLst>
   <p:sldSz cy="5143500" cx="9144000"/>
   <p:notesSz cx="6858000" cy="9144000"/>
@@ -6988,7 +6986,6 @@
                 <a:solidFill>
                   <a:srgbClr val="0D9488"/>
                 </a:solidFill>
-                <a:latin typeface="Arial"/>
               </a:defRPr>
             </a:pPr>
             <a:r>
@@ -7003,7 +7000,7 @@
           </a:p>
           <a:p>
             <a:pPr>
-              <a:defRPr sz="1400" b="1">
+              <a:defRPr sz="1350" b="1">
                 <a:solidFill>
                   <a:srgbClr val="0F172A"/>
                 </a:solidFill>
@@ -7022,7 +7019,7 @@
               </a:defRPr>
             </a:pPr>
             <a:r>
-              <a:t>AI Builder Cup 2026 | Track: Sustainability &amp; Social Impact</a:t>
+              <a:t>AI Builder Cup 2026 | Category: Sustainability &amp; Social Impact</a:t>
             </a:r>
           </a:p>
           <a:p>
@@ -7040,14 +7037,14 @@
           </a:p>
           <a:p>
             <a:pPr>
-              <a:defRPr sz="1100">
+              <a:defRPr sz="1150" b="1">
                 <a:solidFill>
                   <a:srgbClr val="0F172A"/>
                 </a:solidFill>
               </a:defRPr>
             </a:pPr>
             <a:r>
-              <a:t>• Team Name: CivicLens Innovators</a:t>
+              <a:t>• Team Name: CivicLens Innovators (Agrim Jain, Adete Jain)</a:t>
             </a:r>
           </a:p>
           <a:p>
@@ -7059,19 +7056,31 @@
               </a:defRPr>
             </a:pPr>
             <a:r>
-              <a:t>• Team Leader Name: Agrim Jain (Lead AI &amp; Cloud Architect / Full-Stack Engineer)</a:t>
+              <a:t>• Team Leader Name: Agrim Jain</a:t>
             </a:r>
           </a:p>
           <a:p>
             <a:pPr>
-              <a:defRPr sz="1050">
+              <a:defRPr sz="1100">
+                <a:solidFill>
+                  <a:srgbClr val="0F172A"/>
+                </a:solidFill>
+              </a:defRPr>
+            </a:pPr>
+            <a:r>
+              <a:t>• Team Members: Agrim Jain, Adete Jain</a:t>
+            </a:r>
+          </a:p>
+          <a:p>
+            <a:pPr>
+              <a:defRPr sz="1000">
                 <a:solidFill>
                   <a:srgbClr val="64748B"/>
                 </a:solidFill>
               </a:defRPr>
             </a:pPr>
             <a:r>
-              <a:t>• Problem Statement: Urban municipal systems suffer from high citizen friction (text-heavy, English-only portals), overwhelming duplicate backlogs for local bodies, lack of automated hazard triage, and systemic 'ghost ticket resolutions' where cases are closed without verifiable photographic ground proof or citizen dispute oversight.</a:t>
+              <a:t>• Problem Statement: Municipal systems suffer from high reporting friction, overwhelming duplicate backlogs, lack of automated hazard triage, and premature 'ghost ticket resolutions' without verifiable ground truth or citizen veto oversight.</a:t>
             </a:r>
           </a:p>
         </p:txBody>
@@ -10282,14 +10291,87 @@
                 <a:spcPts val="0"/>
               </a:spcAft>
               <a:buNone/>
-              <a:defRPr sz="2200" b="1">
-                <a:solidFill>
-                  <a:srgbClr val="0F172A"/>
-                </a:solidFill>
-              </a:defRPr>
-            </a:pPr>
-            <a:r>
-              <a:t>Executive Summary &amp; Core Impact</a:t>
+            </a:pPr>
+            <a:r>
+              <a:rPr lang="en-GB" sz="1100">
+                <a:solidFill>
+                  <a:schemeClr val="lt1"/>
+                </a:solidFill>
+                <a:latin typeface="Google Sans Flex Medium"/>
+                <a:ea typeface="Google Sans Flex Medium"/>
+                <a:cs typeface="Google Sans Flex Medium"/>
+                <a:sym typeface="Google Sans Flex Medium"/>
+              </a:rPr>
+              <a:t>Note:</a:t>
+            </a:r>
+            <a:r>
+              <a:rPr lang="en-GB" sz="1100">
+                <a:solidFill>
+                  <a:schemeClr val="lt1"/>
+                </a:solidFill>
+                <a:latin typeface="Google Sans Flex"/>
+                <a:ea typeface="Google Sans Flex"/>
+                <a:cs typeface="Google Sans Flex"/>
+                <a:sym typeface="Google Sans Flex"/>
+              </a:rPr>
+              <a:t> Please download this template to make your edits and submit the final version.</a:t>
+            </a:r>
+            <a:br>
+              <a:rPr lang="en-GB" sz="1100">
+                <a:solidFill>
+                  <a:schemeClr val="lt1"/>
+                </a:solidFill>
+                <a:latin typeface="Google Sans Flex"/>
+                <a:ea typeface="Google Sans Flex"/>
+                <a:cs typeface="Google Sans Flex"/>
+                <a:sym typeface="Google Sans Flex"/>
+              </a:rPr>
+            </a:br>
+            <a:br>
+              <a:rPr lang="en-GB" sz="1100">
+                <a:solidFill>
+                  <a:schemeClr val="lt1"/>
+                </a:solidFill>
+                <a:latin typeface="Google Sans Flex"/>
+                <a:ea typeface="Google Sans Flex"/>
+                <a:cs typeface="Google Sans Flex"/>
+                <a:sym typeface="Google Sans Flex"/>
+              </a:rPr>
+            </a:br>
+            <a:r>
+              <a:rPr lang="en-GB" sz="1100">
+                <a:solidFill>
+                  <a:schemeClr val="lt1"/>
+                </a:solidFill>
+                <a:latin typeface="Google Sans Flex"/>
+                <a:ea typeface="Google Sans Flex"/>
+                <a:cs typeface="Google Sans Flex"/>
+                <a:sym typeface="Google Sans Flex"/>
+              </a:rPr>
+              <a:t>To download, go to File &gt; Download &gt; Microsoft PowerPoint (.PPTX). Kindly refrain from sending edit requests.</a:t>
+            </a:r>
+            <a:endParaRPr sz="1100">
+              <a:solidFill>
+                <a:schemeClr val="lt1"/>
+              </a:solidFill>
+              <a:latin typeface="Google Sans Flex"/>
+              <a:ea typeface="Google Sans Flex"/>
+              <a:cs typeface="Google Sans Flex"/>
+              <a:sym typeface="Google Sans Flex"/>
+            </a:endParaRPr>
+          </a:p>
+          <a:p>
+            <a:pPr indent="0" lvl="0" marL="0" rtl="0" algn="l">
+              <a:spcBef>
+                <a:spcPts val="0"/>
+              </a:spcBef>
+              <a:spcAft>
+                <a:spcPts val="0"/>
+              </a:spcAft>
+              <a:buNone/>
+            </a:pPr>
+            <a:r>
+              <a:t/>
             </a:r>
             <a:endParaRPr sz="1100">
               <a:solidFill>
@@ -10338,210 +10420,6 @@
           </a:effectLst>
         </p:spPr>
       </p:pic>
-      <p:sp>
-        <p:nvSpPr>
-          <p:cNvPr id="65" name="Rounded Rectangle 64"/>
-          <p:cNvSpPr/>
-          <p:nvPr/>
-        </p:nvSpPr>
-        <p:spPr>
-          <a:xfrm>
-            <a:off x="457200" y="1280160"/>
-            <a:ext cx="3931920" cy="3017520"/>
-          </a:xfrm>
-          <a:prstGeom prst="roundRect">
-            <a:avLst/>
-          </a:prstGeom>
-          <a:solidFill>
-            <a:srgbClr val="F8FAFC"/>
-          </a:solidFill>
-          <a:ln w="15240">
-            <a:solidFill>
-              <a:srgbClr val="CBD5E1"/>
-            </a:solidFill>
-          </a:ln>
-        </p:spPr>
-        <p:style>
-          <a:lnRef idx="1">
-            <a:schemeClr val="accent1"/>
-          </a:lnRef>
-          <a:fillRef idx="3">
-            <a:schemeClr val="accent1"/>
-          </a:fillRef>
-          <a:effectRef idx="2">
-            <a:schemeClr val="accent1"/>
-          </a:effectRef>
-          <a:fontRef idx="minor">
-            <a:schemeClr val="lt1"/>
-          </a:fontRef>
-        </p:style>
-        <p:txBody>
-          <a:bodyPr rtlCol="0" anchor="ctr" wrap="square"/>
-          <a:lstStyle/>
-          <a:p>
-            <a:pPr algn="ctr">
-              <a:defRPr sz="1400" b="1">
-                <a:solidFill>
-                  <a:srgbClr val="DC2626"/>
-                </a:solidFill>
-              </a:defRPr>
-            </a:pPr>
-            <a:r>
-              <a:t>The Municipal Redressal Breakdown</a:t>
-            </a:r>
-          </a:p>
-          <a:p>
-            <a:pPr>
-              <a:defRPr sz="1000">
-                <a:solidFill>
-                  <a:srgbClr val="0F172A"/>
-                </a:solidFill>
-              </a:defRPr>
-            </a:pPr>
-            <a:r>
-              <a:t>• Citizens Face High Friction: 68% drop-off rate on traditional portals due to rigid forms and language barriers.</a:t>
-            </a:r>
-          </a:p>
-          <a:p>
-            <a:pPr>
-              <a:defRPr sz="1000">
-                <a:solidFill>
-                  <a:srgbClr val="0F172A"/>
-                </a:solidFill>
-              </a:defRPr>
-            </a:pPr>
-            <a:r>
-              <a:t>• Municipalities Paralyzed: Thousands of unstructured, duplicate reports overload triage desks without actionable priority context.</a:t>
-            </a:r>
-          </a:p>
-          <a:p>
-            <a:pPr>
-              <a:defRPr sz="1000">
-                <a:solidFill>
-                  <a:srgbClr val="0F172A"/>
-                </a:solidFill>
-              </a:defRPr>
-            </a:pPr>
-            <a:r>
-              <a:t>• Ghost Ticket Closures: Complaints routinely marked 'resolved' by contractors with zero photographic evidence.</a:t>
-            </a:r>
-          </a:p>
-          <a:p>
-            <a:pPr>
-              <a:defRPr sz="1000">
-                <a:solidFill>
-                  <a:srgbClr val="0F172A"/>
-                </a:solidFill>
-              </a:defRPr>
-            </a:pPr>
-            <a:r>
-              <a:t>• Dangerous Hazards Ignored: Exposed live wires, water contamination, and severe road collapse left unattended for weeks.</a:t>
-            </a:r>
-          </a:p>
-        </p:txBody>
-      </p:sp>
-      <p:sp>
-        <p:nvSpPr>
-          <p:cNvPr id="66" name="Rounded Rectangle 65"/>
-          <p:cNvSpPr/>
-          <p:nvPr/>
-        </p:nvSpPr>
-        <p:spPr>
-          <a:xfrm>
-            <a:off x="4572000" y="1280160"/>
-            <a:ext cx="4114800" cy="3017520"/>
-          </a:xfrm>
-          <a:prstGeom prst="roundRect">
-            <a:avLst/>
-          </a:prstGeom>
-          <a:solidFill>
-            <a:srgbClr val="F8FAFC"/>
-          </a:solidFill>
-          <a:ln w="15240">
-            <a:solidFill>
-              <a:srgbClr val="CBD5E1"/>
-            </a:solidFill>
-          </a:ln>
-        </p:spPr>
-        <p:style>
-          <a:lnRef idx="1">
-            <a:schemeClr val="accent1"/>
-          </a:lnRef>
-          <a:fillRef idx="3">
-            <a:schemeClr val="accent1"/>
-          </a:fillRef>
-          <a:effectRef idx="2">
-            <a:schemeClr val="accent1"/>
-          </a:effectRef>
-          <a:fontRef idx="minor">
-            <a:schemeClr val="lt1"/>
-          </a:fontRef>
-        </p:style>
-        <p:txBody>
-          <a:bodyPr rtlCol="0" anchor="ctr" wrap="square"/>
-          <a:lstStyle/>
-          <a:p>
-            <a:pPr algn="ctr">
-              <a:defRPr sz="1400" b="1">
-                <a:solidFill>
-                  <a:srgbClr val="059669"/>
-                </a:solidFill>
-              </a:defRPr>
-            </a:pPr>
-            <a:r>
-              <a:t>The CivicLens AI Transformation</a:t>
-            </a:r>
-          </a:p>
-          <a:p>
-            <a:pPr>
-              <a:defRPr sz="1000">
-                <a:solidFill>
-                  <a:srgbClr val="0F172A"/>
-                </a:solidFill>
-              </a:defRPr>
-            </a:pPr>
-            <a:r>
-              <a:t>• 30-Second Multimodal Ingestion: Instant camera snapshot, regional voice memo in Hindi &amp; 9 languages, and 1-click GPS.</a:t>
-            </a:r>
-          </a:p>
-          <a:p>
-            <a:pPr>
-              <a:defRPr sz="1000">
-                <a:solidFill>
-                  <a:srgbClr val="0F172A"/>
-                </a:solidFill>
-              </a:defRPr>
-            </a:pPr>
-            <a:r>
-              <a:t>• Gemini Multimodal AI: Concurrent audio &amp; image analysis, structured classification, and explainable P1-P4 priority scoring in &lt; 2s.</a:t>
-            </a:r>
-          </a:p>
-          <a:p>
-            <a:pPr>
-              <a:defRPr sz="1000">
-                <a:solidFill>
-                  <a:srgbClr val="0F172A"/>
-                </a:solidFill>
-              </a:defRPr>
-            </a:pPr>
-            <a:r>
-              <a:t>• Deterministic Spatial Deduplication: Haversine (250m) + Jaccard token clustering merges duplicate reports automatically.</a:t>
-            </a:r>
-          </a:p>
-          <a:p>
-            <a:pPr>
-              <a:defRPr sz="1000">
-                <a:solidFill>
-                  <a:srgbClr val="0F172A"/>
-                </a:solidFill>
-              </a:defRPr>
-            </a:pPr>
-            <a:r>
-              <a:t>• Closed-Loop Citizen Veto: Mandatory before-and-after photo proof verified by AI, with 1-click citizen right to reopen unfixed work.</a:t>
-            </a:r>
-          </a:p>
-        </p:txBody>
-      </p:sp>
     </p:spTree>
   </p:cSld>
   <p:clrMapOvr>
@@ -10739,55 +10617,67 @@
               </a:defRPr>
             </a:pPr>
             <a:r>
-              <a:t>AI-Driven Citizen Empowerment</a:t>
+              <a:t>Zero-Friction Citizen Ingestion</a:t>
             </a:r>
           </a:p>
           <a:p>
             <a:pPr>
-              <a:defRPr sz="950">
+              <a:defRPr sz="900">
                 <a:solidFill>
                   <a:srgbClr val="0F172A"/>
                 </a:solidFill>
               </a:defRPr>
             </a:pPr>
             <a:r>
-              <a:t>• Zero-Typing Experience: Citizens simply point their camera, speak in their native dialect (Hindi, Punjabi, Tamil, etc.), and tap submit.</a:t>
+              <a:t>• 30-Second Reporting: Citizen captures live camera photo, records voice memo in Hindi or regional tongue, and 1-click pins GPS.</a:t>
             </a:r>
           </a:p>
           <a:p>
             <a:pPr>
-              <a:defRPr sz="950">
+              <a:defRPr sz="900">
                 <a:solidFill>
                   <a:srgbClr val="0F172A"/>
                 </a:solidFill>
               </a:defRPr>
             </a:pPr>
             <a:r>
-              <a:t>• Smart Voice Clarity Nudge: Audio under 4 words or muffled automatically prompts an interactive clarification dialog.</a:t>
+              <a:t>• Multimodal Gemini AI: Concurrent audio &amp; visual analysis, standardizing descriptions, identifying hazards, and assigning P1–P4 priorities.</a:t>
             </a:r>
           </a:p>
           <a:p>
             <a:pPr>
-              <a:defRPr sz="950">
+              <a:defRPr sz="900">
                 <a:solidFill>
                   <a:srgbClr val="0F172A"/>
                 </a:solidFill>
               </a:defRPr>
             </a:pPr>
             <a:r>
-              <a:t>• Life-Safety Crisis Detection: Detects distress triggers (harassment, abuse, safety) and displays direct 1-click hotlines (14416, 1091, 1098).</a:t>
+              <a:t>• Voice Clarity Nudge Modal: Unclear audio (&lt;4 words or muffled) prompts citizen with 1-click category override dialog.</a:t>
             </a:r>
           </a:p>
           <a:p>
             <a:pPr>
-              <a:defRPr sz="950">
+              <a:defRPr sz="900">
                 <a:solidFill>
                   <a:srgbClr val="0F172A"/>
                 </a:solidFill>
               </a:defRPr>
             </a:pPr>
             <a:r>
-              <a:t>• Transparent Incident Lifecycle: Citizens track repairs in real-time, modify reports, and listen back to their recorded audio notes.</a:t>
+              <a:t>• Life-Safety Crisis Trigger: Distress cues automatically render clickable national helpline buttons (Tele-MANAS 14416, 1091, 1098).</a:t>
+            </a:r>
+          </a:p>
+          <a:p>
+            <a:pPr>
+              <a:defRPr sz="900">
+                <a:solidFill>
+                  <a:srgbClr val="0F172A"/>
+                </a:solidFill>
+              </a:defRPr>
+            </a:pPr>
+            <a:r>
+              <a:t>• Citizen Audio Playback: Recorded voice notes can be replayed anytime from 'My Requests'.</a:t>
             </a:r>
           </a:p>
         </p:txBody>
@@ -10841,55 +10731,67 @@
               </a:defRPr>
             </a:pPr>
             <a:r>
-              <a:t>End-to-End Municipal Intelligence</a:t>
+              <a:t>Closed-Loop Municipal Accountability</a:t>
             </a:r>
           </a:p>
           <a:p>
             <a:pPr>
-              <a:defRPr sz="950">
+              <a:defRPr sz="900">
                 <a:solidFill>
                   <a:srgbClr val="0F172A"/>
                 </a:solidFill>
               </a:defRPr>
             </a:pPr>
             <a:r>
-              <a:t>• Spatial Clustering Engine: Haversine distance (&lt;250m) clusters duplicate complaints to avoid dispatching multiple trucks to the same site.</a:t>
+              <a:t>• Spatial Deduplication Engine: Haversine distance (250m) + lexical Jaccard token clustering merges duplicate reports automatically.</a:t>
             </a:r>
           </a:p>
           <a:p>
             <a:pPr>
-              <a:defRPr sz="950">
+              <a:defRPr sz="900">
                 <a:solidFill>
                   <a:srgbClr val="0F172A"/>
                 </a:solidFill>
               </a:defRPr>
             </a:pPr>
             <a:r>
-              <a:t>• Explainable Priority SLAs: Assigns P1 (Emergency 4-hr) to P4 (Low 7-day) with plain-language technical justifications for municipal crews.</a:t>
+              <a:t>• Explainable Priority Scoring: Generates plain-language technical justifications for municipal crews (e.g. live wire shock risk).</a:t>
             </a:r>
           </a:p>
           <a:p>
             <a:pPr>
-              <a:defRPr sz="950">
+              <a:defRPr sz="900">
                 <a:solidFill>
                   <a:srgbClr val="0F172A"/>
                 </a:solidFill>
               </a:defRPr>
             </a:pPr>
             <a:r>
-              <a:t>• Advisory AI Verification: Compares 'before' citizen evidence against 'after' repair photos uploaded by municipal field crews.</a:t>
+              <a:t>• Mandatory Ground Verification: Field repair crews upload 'after-repair' photos inspected by advisory Gemini AI.</a:t>
             </a:r>
           </a:p>
           <a:p>
             <a:pPr>
-              <a:defRPr sz="950">
+              <a:defRPr sz="900">
                 <a:solidFill>
                   <a:srgbClr val="0F172A"/>
                 </a:solidFill>
               </a:defRPr>
             </a:pPr>
             <a:r>
-              <a:t>• Citizen Veto Guarantee: Cases cannot be secretly signed off. Citizens hold the final word to dispute and escalate unresolved hazards.</a:t>
+              <a:t>• Citizen Veto Reopen Right: If work is substandard or falsified, citizens retain a 1-click dispute right to reopen the case.</a:t>
+            </a:r>
+          </a:p>
+          <a:p>
+            <a:pPr>
+              <a:defRPr sz="900">
+                <a:solidFill>
+                  <a:srgbClr val="0F172A"/>
+                </a:solidFill>
+              </a:defRPr>
+            </a:pPr>
+            <a:r>
+              <a:t>• Immutable Audit Trail: Chronological event ledger tracking every status change, assignment, and evidence upload.</a:t>
             </a:r>
           </a:p>
         </p:txBody>
@@ -11269,7 +11171,7 @@
                         </a:defRPr>
                       </a:pPr>
                       <a:r>
-                        <a:t>Camera snapshot, regional voice memo (Hindi/10 langs), 1-click GPS</a:t>
+                        <a:t>Camera snapshot, native voice memo (Hindi/10 langs), 1-click GPS</a:t>
                       </a:r>
                     </a:p>
                   </a:txBody>
@@ -11551,7 +11453,7 @@
                         </a:defRPr>
                       </a:pPr>
                       <a:r>
-                        <a:t>Mandatory Before/After photo proof + 1-Click Citizen Veto / Reopen right</a:t>
+                        <a:t>Mandatory Before/After photo proof + 1-Click Citizen Veto right</a:t>
                       </a:r>
                     </a:p>
                   </a:txBody>

</xml_diff>